<commit_message>
improve class 03 - week 5
</commit_message>
<xml_diff>
--- a/clases/semana-05/03/ppt/Clase-15-Agentes-IA-en-Desarrollo.pptx
+++ b/clases/semana-05/03/ppt/Clase-15-Agentes-IA-en-Desarrollo.pptx
@@ -30220,9 +30220,9 @@
           <p:nvPr/>
         </p:nvSpPr>
         <p:spPr>
-          <a:xfrm rot="14400000">
-            <a:off x="4045634" y="5184648"/>
-            <a:ext cx="365760" cy="365760"/>
+          <a:xfrm rot="3600000">
+            <a:off x="6577900" y="3794760"/>
+            <a:ext cx="274320" cy="274320"/>
           </a:xfrm>
           <a:prstGeom prst="rightArrow">
             <a:avLst/>
@@ -30387,8 +30387,8 @@
         </p:nvSpPr>
         <p:spPr>
           <a:xfrm rot="10800000">
-            <a:off x="5312664" y="5916168"/>
-            <a:ext cx="365760" cy="365760"/>
+            <a:off x="5358384" y="5907024"/>
+            <a:ext cx="274320" cy="274320"/>
           </a:xfrm>
           <a:prstGeom prst="rightArrow">
             <a:avLst/>
@@ -30553,8 +30553,8 @@
         </p:nvSpPr>
         <p:spPr>
           <a:xfrm rot="18000000">
-            <a:off x="4045634" y="3721608"/>
-            <a:ext cx="365760" cy="365760"/>
+            <a:off x="4138868" y="3794760"/>
+            <a:ext cx="274320" cy="274320"/>
           </a:xfrm>
           <a:prstGeom prst="rightArrow">
             <a:avLst/>
@@ -30578,7 +30578,7 @@
         </p:nvSpPr>
         <p:spPr>
           <a:xfrm>
-            <a:off x="4123944" y="4544568"/>
+            <a:off x="4123944" y="4315968"/>
             <a:ext cx="2743200" cy="274320"/>
           </a:xfrm>
           <a:prstGeom prst="rect">

</xml_diff>